<commit_message>
Consejo LLM #02 + iteración 2: 6 mejoras de cierre, cumplimiento y alcance
- (alta) Tangible del viernes sin violar Decreto 144: CV anonimizado por correo -> teaser en
  entorno con DPA; ATS+abogado el lunes; demo completa (20-30 CVs) dentro de Fase 0.
- (alta) Guatemala en riesgos + transferencia SV-GT; taxonomía desplegable en SV y GT.
- (media) Tablero de línea base condicional; jerga de Fase 1 -> resultados de negocio;
  seguro del comprador si la Puerta 0 sale roja; alivio operativo en 3 semanas en doc cliente.
- Reflejado en PDF (17pp), deck (19 slides) y propuesta interna. Glyph SV-GT corregido.

Co-Authored-By: Claude Opus 4.8 <noreply@anthropic.com>
</commit_message>
<xml_diff>
--- a/04-propuesta/Presentacion-Conexion-Talento.pptx
+++ b/04-propuesta/Presentacion-Conexion-Talento.pptx
@@ -4639,17 +4639,39 @@
                 <a:spcPts val="0"/>
               </a:spcBef>
               <a:spcAft>
+                <a:spcPts val="300"/>
+              </a:spcAft>
+            </a:pPr>
+            <a:r>
+              <a:rPr sz="1250" b="0">
+                <a:solidFill>
+                  <a:srgbClr val="5B6B7B"/>
+                </a:solidFill>
+                <a:latin typeface="Arial"/>
+              </a:rPr>
+              <a:t>Factibilidad pagada + 2 quick wins · 2–3 semanas · 100% acreditable a la siguiente fase</a:t>
+            </a:r>
+          </a:p>
+          <a:p>
+            <a:pPr algn="l">
+              <a:lnSpc>
+                <a:spcPct val="108000"/>
+              </a:lnSpc>
+              <a:spcBef>
+                <a:spcPts val="0"/>
+              </a:spcBef>
+              <a:spcAft>
                 <a:spcPts val="400"/>
               </a:spcAft>
             </a:pPr>
             <a:r>
-              <a:rPr sz="1250" b="0">
-                <a:solidFill>
-                  <a:srgbClr val="5B6B7B"/>
-                </a:solidFill>
-                <a:latin typeface="Arial"/>
-              </a:rPr>
-              <a:t>Factibilidad pagada + 2 quick wins · 2–3 semanas · 100% acreditable a la siguiente fase</a:t>
+              <a:rPr sz="1200" b="1">
+                <a:solidFill>
+                  <a:srgbClr val="1C7C8C"/>
+                </a:solidFill>
+                <a:latin typeface="Arial"/>
+              </a:rPr>
+              <a:t>Tu seguro: los activos tangibles son tuyos aunque la Puerta 0 salga roja y no continúes.</a:t>
             </a:r>
           </a:p>
         </p:txBody>
@@ -5631,7 +5653,7 @@
         </p:nvGraphicFramePr>
         <p:xfrm>
           <a:off x="640080" y="1600200"/>
-          <a:ext cx="10908792" cy="4389120"/>
+          <a:ext cx="10908792" cy="4224528"/>
         </p:xfrm>
         <a:graphic>
           <a:graphicData uri="http://schemas.openxmlformats.org/drawingml/2006/table">
@@ -5643,7 +5665,7 @@
                 <a:gridCol w="4206240"/>
                 <a:gridCol w="6702552"/>
               </a:tblGrid>
-              <a:tr h="731520">
+              <a:tr h="603504">
                 <a:tc>
                   <a:txBody>
                     <a:bodyPr wrap="square"/>
@@ -5689,14 +5711,14 @@
                   </a:tcPr>
                 </a:tc>
               </a:tr>
-              <a:tr h="731520">
+              <a:tr h="603504">
                 <a:tc>
                   <a:txBody>
                     <a:bodyPr wrap="square"/>
                     <a:lstStyle/>
                     <a:p>
                       <a:r>
-                        <a:rPr sz="1150" b="1">
+                        <a:rPr sz="1050" b="1">
                           <a:solidFill>
                             <a:srgbClr val="102A43"/>
                           </a:solidFill>
@@ -5718,7 +5740,7 @@
                     <a:lstStyle/>
                     <a:p>
                       <a:r>
-                        <a:rPr sz="1150">
+                        <a:rPr sz="1050">
                           <a:solidFill>
                             <a:srgbClr val="1A2733"/>
                           </a:solidFill>
@@ -5735,14 +5757,14 @@
                   </a:tcPr>
                 </a:tc>
               </a:tr>
-              <a:tr h="731520">
+              <a:tr h="603504">
                 <a:tc>
                   <a:txBody>
                     <a:bodyPr wrap="square"/>
                     <a:lstStyle/>
                     <a:p>
                       <a:r>
-                        <a:rPr sz="1150" b="1">
+                        <a:rPr sz="1050" b="1">
                           <a:solidFill>
                             <a:srgbClr val="102A43"/>
                           </a:solidFill>
@@ -5764,7 +5786,7 @@
                     <a:lstStyle/>
                     <a:p>
                       <a:r>
-                        <a:rPr sz="1150">
+                        <a:rPr sz="1050">
                           <a:solidFill>
                             <a:srgbClr val="1A2733"/>
                           </a:solidFill>
@@ -5781,14 +5803,14 @@
                   </a:tcPr>
                 </a:tc>
               </a:tr>
-              <a:tr h="731520">
+              <a:tr h="603504">
                 <a:tc>
                   <a:txBody>
                     <a:bodyPr wrap="square"/>
                     <a:lstStyle/>
                     <a:p>
                       <a:r>
-                        <a:rPr sz="1150" b="1">
+                        <a:rPr sz="1050" b="1">
                           <a:solidFill>
                             <a:srgbClr val="102A43"/>
                           </a:solidFill>
@@ -5810,7 +5832,7 @@
                     <a:lstStyle/>
                     <a:p>
                       <a:r>
-                        <a:rPr sz="1150">
+                        <a:rPr sz="1050">
                           <a:solidFill>
                             <a:srgbClr val="1A2733"/>
                           </a:solidFill>
@@ -5827,14 +5849,14 @@
                   </a:tcPr>
                 </a:tc>
               </a:tr>
-              <a:tr h="731520">
+              <a:tr h="603504">
                 <a:tc>
                   <a:txBody>
                     <a:bodyPr wrap="square"/>
                     <a:lstStyle/>
                     <a:p>
                       <a:r>
-                        <a:rPr sz="1150" b="1">
+                        <a:rPr sz="1050" b="1">
                           <a:solidFill>
                             <a:srgbClr val="102A43"/>
                           </a:solidFill>
@@ -5856,7 +5878,7 @@
                     <a:lstStyle/>
                     <a:p>
                       <a:r>
-                        <a:rPr sz="1150">
+                        <a:rPr sz="1050">
                           <a:solidFill>
                             <a:srgbClr val="1A2733"/>
                           </a:solidFill>
@@ -5873,20 +5895,20 @@
                   </a:tcPr>
                 </a:tc>
               </a:tr>
-              <a:tr h="731520">
+              <a:tr h="603504">
                 <a:tc>
                   <a:txBody>
                     <a:bodyPr wrap="square"/>
                     <a:lstStyle/>
                     <a:p>
                       <a:r>
-                        <a:rPr sz="1150" b="1">
+                        <a:rPr sz="1050" b="1">
                           <a:solidFill>
                             <a:srgbClr val="102A43"/>
                           </a:solidFill>
                           <a:latin typeface="Arial"/>
                         </a:rPr>
-                        <a:t>Adopción del equipo</a:t>
+                        <a:t>Datos en Guatemala (transferencia SV–GT)</a:t>
                       </a:r>
                     </a:p>
                   </a:txBody>
@@ -5902,7 +5924,53 @@
                     <a:lstStyle/>
                     <a:p>
                       <a:r>
-                        <a:rPr sz="1150">
+                        <a:rPr sz="1050">
+                          <a:solidFill>
+                            <a:srgbClr val="1A2733"/>
+                          </a:solidFill>
+                          <a:latin typeface="Arial"/>
+                        </a:rPr>
+                        <a:t>R&amp;S opera en SV+GT. GT aún sin ley general; transferencia con DPA y minimización. El estándar se construye una vez y se despliega en ambos países</a:t>
+                      </a:r>
+                    </a:p>
+                  </a:txBody>
+                  <a:tcPr marT="38100" marB="38100" marL="76200" marR="76200" anchor="ctr">
+                    <a:solidFill>
+                      <a:srgbClr val="FFFFFF"/>
+                    </a:solidFill>
+                  </a:tcPr>
+                </a:tc>
+              </a:tr>
+              <a:tr h="603504">
+                <a:tc>
+                  <a:txBody>
+                    <a:bodyPr wrap="square"/>
+                    <a:lstStyle/>
+                    <a:p>
+                      <a:r>
+                        <a:rPr sz="1050" b="1">
+                          <a:solidFill>
+                            <a:srgbClr val="102A43"/>
+                          </a:solidFill>
+                          <a:latin typeface="Arial"/>
+                        </a:rPr>
+                        <a:t>Adopción del equipo</a:t>
+                      </a:r>
+                    </a:p>
+                  </a:txBody>
+                  <a:tcPr marT="38100" marB="38100" marL="76200" marR="76200" anchor="ctr">
+                    <a:solidFill>
+                      <a:srgbClr val="F5F7FA"/>
+                    </a:solidFill>
+                  </a:tcPr>
+                </a:tc>
+                <a:tc>
+                  <a:txBody>
+                    <a:bodyPr wrap="square"/>
+                    <a:lstStyle/>
+                    <a:p>
+                      <a:r>
+                        <a:rPr sz="1050">
                           <a:solidFill>
                             <a:srgbClr val="1A2733"/>
                           </a:solidFill>
@@ -5914,7 +5982,7 @@
                   </a:txBody>
                   <a:tcPr marT="38100" marB="38100" marL="76200" marR="76200" anchor="ctr">
                     <a:solidFill>
-                      <a:srgbClr val="FFFFFF"/>
+                      <a:srgbClr val="F5F7FA"/>
                     </a:solidFill>
                   </a:tcPr>
                 </a:tc>
@@ -11199,7 +11267,7 @@
                 </a:solidFill>
                 <a:latin typeface="Arial"/>
               </a:rPr>
-              <a:t>Accesos a Team Tailor (lectura/export) — esta semana.</a:t>
+              <a:t>Un CV real anonimizado (por correo) — para el teaser del viernes.</a:t>
             </a:r>
           </a:p>
           <a:p>
@@ -11230,69 +11298,69 @@
                 </a:solidFill>
                 <a:latin typeface="Arial"/>
               </a:rPr>
+              <a:t>Acceso de lectura a Team Tailor — el lunes (lead time).</a:t>
+            </a:r>
+          </a:p>
+          <a:p>
+            <a:pPr algn="l">
+              <a:lnSpc>
+                <a:spcPct val="115000"/>
+              </a:lnSpc>
+              <a:spcBef>
+                <a:spcPts val="0"/>
+              </a:spcBef>
+              <a:spcAft>
+                <a:spcPts val="800"/>
+              </a:spcAft>
+            </a:pPr>
+            <a:r>
+              <a:rPr sz="1300" b="1">
+                <a:solidFill>
+                  <a:srgbClr val="1C7C8C"/>
+                </a:solidFill>
+                <a:latin typeface="Arial"/>
+              </a:rPr>
+              <a:t>•  </a:t>
+            </a:r>
+            <a:r>
+              <a:rPr sz="1300" b="0">
+                <a:solidFill>
+                  <a:srgbClr val="1A2733"/>
+                </a:solidFill>
+                <a:latin typeface="Arial"/>
+              </a:rPr>
+              <a:t>Contacto de tu abogado/a — el lunes.</a:t>
+            </a:r>
+          </a:p>
+          <a:p>
+            <a:pPr algn="l">
+              <a:lnSpc>
+                <a:spcPct val="115000"/>
+              </a:lnSpc>
+              <a:spcBef>
+                <a:spcPts val="0"/>
+              </a:spcBef>
+              <a:spcAft>
+                <a:spcPts val="800"/>
+              </a:spcAft>
+            </a:pPr>
+            <a:r>
+              <a:rPr sz="1300" b="1">
+                <a:solidFill>
+                  <a:srgbClr val="1C7C8C"/>
+                </a:solidFill>
+                <a:latin typeface="Arial"/>
+              </a:rPr>
+              <a:t>•  </a:t>
+            </a:r>
+            <a:r>
+              <a:rPr sz="1300" b="0">
+                <a:solidFill>
+                  <a:srgbClr val="1A2733"/>
+                </a:solidFill>
+                <a:latin typeface="Arial"/>
+              </a:rPr>
               <a:t>Fee por colocación + volumen de mandatos/mes.</a:t>
-            </a:r>
-          </a:p>
-          <a:p>
-            <a:pPr algn="l">
-              <a:lnSpc>
-                <a:spcPct val="115000"/>
-              </a:lnSpc>
-              <a:spcBef>
-                <a:spcPts val="0"/>
-              </a:spcBef>
-              <a:spcAft>
-                <a:spcPts val="800"/>
-              </a:spcAft>
-            </a:pPr>
-            <a:r>
-              <a:rPr sz="1300" b="1">
-                <a:solidFill>
-                  <a:srgbClr val="1C7C8C"/>
-                </a:solidFill>
-                <a:latin typeface="Arial"/>
-              </a:rPr>
-              <a:t>•  </a:t>
-            </a:r>
-            <a:r>
-              <a:rPr sz="1300" b="0">
-                <a:solidFill>
-                  <a:srgbClr val="1A2733"/>
-                </a:solidFill>
-                <a:latin typeface="Arial"/>
-              </a:rPr>
-              <a:t>Una vacante abierta para la demo viva.</a:t>
-            </a:r>
-          </a:p>
-          <a:p>
-            <a:pPr algn="l">
-              <a:lnSpc>
-                <a:spcPct val="115000"/>
-              </a:lnSpc>
-              <a:spcBef>
-                <a:spcPts val="0"/>
-              </a:spcBef>
-              <a:spcAft>
-                <a:spcPts val="800"/>
-              </a:spcAft>
-            </a:pPr>
-            <a:r>
-              <a:rPr sz="1300" b="1">
-                <a:solidFill>
-                  <a:srgbClr val="1C7C8C"/>
-                </a:solidFill>
-                <a:latin typeface="Arial"/>
-              </a:rPr>
-              <a:t>•  </a:t>
-            </a:r>
-            <a:r>
-              <a:rPr sz="1300" b="0">
-                <a:solidFill>
-                  <a:srgbClr val="1A2733"/>
-                </a:solidFill>
-                <a:latin typeface="Arial"/>
-              </a:rPr>
-              <a:t>Horas protegidas de Virginia (golden set).</a:t>
             </a:r>
           </a:p>
           <a:p>
@@ -11636,7 +11704,7 @@
                 </a:solidFill>
                 <a:latin typeface="Arial"/>
               </a:rPr>
-              <a:t>Darnos acceso a Team Tailor y una vacante real esta semana.</a:t>
+              <a:t>Hoy: un CV anonimizado por correo → teaser con tu branding esta semana (entorno con DPA).</a:t>
             </a:r>
           </a:p>
         </p:txBody>
@@ -11770,7 +11838,7 @@
                 </a:solidFill>
                 <a:latin typeface="Arial"/>
               </a:rPr>
-              <a:t>Demo viva + semáforo en 2–3 semanas → de ahí cotizamos lo que siga.</a:t>
+              <a:t>Lunes: acceso a Team Tailor + abogado/a. Demo completa + semáforo en 2–3 semanas.</a:t>
             </a:r>
           </a:p>
         </p:txBody>
@@ -17451,7 +17519,7 @@
                 </a:solidFill>
                 <a:latin typeface="Arial"/>
               </a:rPr>
-              <a:t>20–30 CVs reales de una vacante tuya abierta, ordenados con tu criterio replicado — tu ojo clínico hecho herramienta.</a:t>
+              <a:t>20–30 CVs reales de una vacante tuya abierta, ordenados con tu criterio replicado — en un entorno con DPA, cumpliendo desde el día 1.</a:t>
             </a:r>
           </a:p>
         </p:txBody>

</xml_diff>

<commit_message>
Consejo LLM #03 + iteración 3: afinar el cierre comercial del viernes
- (alta) ROI con el fee real (pedirlo HOY por WhatsApp); reconciliar temp+F0=$4.500 vs 5o
  reclutador (~$15k/año) como puente económico; 2o tangible legal el viernes (registro anti-dup
  en vivo); ruta si la F0 sale roja + economía del primer cliente (referencia+IP > margen).
- (media) Autocanibalización de F1 como decisión comercial de Víctor (interna); Puerta 2 honesta
  con el n (cualitativa); licencia DPA visible (herramienta/costo/pagador).
- PDF 17pp + deck 19 slides re-renderizados; interna §11.6 + §11.4.

Co-Authored-By: Claude Opus 4.8 <noreply@anthropic.com>
</commit_message>
<xml_diff>
--- a/04-propuesta/Presentacion-Conexion-Talento.pptx
+++ b/04-propuesta/Presentacion-Conexion-Talento.pptx
@@ -4210,7 +4210,7 @@
                 </a:solidFill>
                 <a:latin typeface="Arial"/>
               </a:rPr>
-              <a:t>todavía no tengo tu fee promedio ni cuántos mandatos manejas al mes. Esos dos datos arman tu ROI real, y son la primera conversación del arranque.</a:t>
+              <a:t>todavía no tengo tu fee promedio ni cuántos mandatos manejas al mes. Mándamelos HOY por WhatsApp y traigo tu ROI con tu número real al viernes —no un ejemplo—.</a:t>
             </a:r>
           </a:p>
           <a:p>
@@ -4729,8 +4729,8 @@
         </p:nvSpPr>
         <p:spPr>
           <a:xfrm>
-            <a:off x="640080" y="3200400"/>
-            <a:ext cx="10911535" cy="320040"/>
+            <a:off x="640080" y="2889504"/>
+            <a:ext cx="10911535" cy="274320"/>
           </a:xfrm>
           <a:prstGeom prst="rect">
             <a:avLst/>
@@ -4745,6 +4745,60 @@
           <a:p>
             <a:pPr algn="l">
               <a:lnSpc>
+                <a:spcPct val="110000"/>
+              </a:lnSpc>
+              <a:spcBef>
+                <a:spcPts val="0"/>
+              </a:spcBef>
+              <a:spcAft>
+                <a:spcPts val="400"/>
+              </a:spcAft>
+            </a:pPr>
+            <a:r>
+              <a:rPr sz="1200" b="1">
+                <a:solidFill>
+                  <a:srgbClr val="C9A227"/>
+                </a:solidFill>
+                <a:latin typeface="Arial"/>
+              </a:rPr>
+              <a:t>La cuenta real:  </a:t>
+            </a:r>
+            <a:r>
+              <a:rPr sz="1200" b="0">
+                <a:solidFill>
+                  <a:srgbClr val="5B6B7B"/>
+                </a:solidFill>
+                <a:latin typeface="Arial"/>
+              </a:rPr>
+              <a:t>temporal (~$2.000) + Fase 0 ($2.500) = $4.500  ·  vs. el 5º reclutador que pediste (~$15k/año). Esa es la vara.</a:t>
+            </a:r>
+          </a:p>
+        </p:txBody>
+      </p:sp>
+      <p:sp>
+        <p:nvSpPr>
+          <p:cNvPr id="12" name="TextBox 11"/>
+          <p:cNvSpPr txBox="1"/>
+          <p:nvPr/>
+        </p:nvSpPr>
+        <p:spPr>
+          <a:xfrm>
+            <a:off x="640080" y="3255264"/>
+            <a:ext cx="10911535" cy="320040"/>
+          </a:xfrm>
+          <a:prstGeom prst="rect">
+            <a:avLst/>
+          </a:prstGeom>
+          <a:noFill/>
+        </p:spPr>
+        <p:txBody>
+          <a:bodyPr wrap="square" anchor="t" lIns="0" rIns="0" tIns="0" bIns="0">
+            <a:spAutoFit/>
+          </a:bodyPr>
+          <a:lstStyle/>
+          <a:p>
+            <a:pPr algn="l">
+              <a:lnSpc>
                 <a:spcPct val="108000"/>
               </a:lnSpc>
               <a:spcBef>
@@ -4768,7 +4822,7 @@
       </p:sp>
       <p:sp>
         <p:nvSpPr>
-          <p:cNvPr id="12" name="Rectangle 11"/>
+          <p:cNvPr id="13" name="Rectangle 12"/>
           <p:cNvSpPr/>
           <p:nvPr/>
         </p:nvSpPr>
@@ -4814,7 +4868,7 @@
       </p:sp>
       <p:sp>
         <p:nvSpPr>
-          <p:cNvPr id="13" name="Rectangle 12"/>
+          <p:cNvPr id="14" name="Rectangle 13"/>
           <p:cNvSpPr/>
           <p:nvPr/>
         </p:nvSpPr>
@@ -4858,7 +4912,7 @@
       </p:sp>
       <p:sp>
         <p:nvSpPr>
-          <p:cNvPr id="14" name="TextBox 13"/>
+          <p:cNvPr id="15" name="TextBox 14"/>
           <p:cNvSpPr txBox="1"/>
           <p:nvPr/>
         </p:nvSpPr>
@@ -4947,7 +5001,7 @@
       </p:sp>
       <p:sp>
         <p:nvSpPr>
-          <p:cNvPr id="15" name="Rectangle 14"/>
+          <p:cNvPr id="16" name="Rectangle 15"/>
           <p:cNvSpPr/>
           <p:nvPr/>
         </p:nvSpPr>
@@ -4993,7 +5047,7 @@
       </p:sp>
       <p:sp>
         <p:nvSpPr>
-          <p:cNvPr id="16" name="Rectangle 15"/>
+          <p:cNvPr id="17" name="Rectangle 16"/>
           <p:cNvSpPr/>
           <p:nvPr/>
         </p:nvSpPr>
@@ -5037,7 +5091,7 @@
       </p:sp>
       <p:sp>
         <p:nvSpPr>
-          <p:cNvPr id="17" name="TextBox 16"/>
+          <p:cNvPr id="18" name="TextBox 17"/>
           <p:cNvSpPr txBox="1"/>
           <p:nvPr/>
         </p:nvSpPr>
@@ -5126,7 +5180,7 @@
       </p:sp>
       <p:sp>
         <p:nvSpPr>
-          <p:cNvPr id="18" name="Rectangle 17"/>
+          <p:cNvPr id="19" name="Rectangle 18"/>
           <p:cNvSpPr/>
           <p:nvPr/>
         </p:nvSpPr>
@@ -5172,7 +5226,7 @@
       </p:sp>
       <p:sp>
         <p:nvSpPr>
-          <p:cNvPr id="19" name="Rectangle 18"/>
+          <p:cNvPr id="20" name="Rectangle 19"/>
           <p:cNvSpPr/>
           <p:nvPr/>
         </p:nvSpPr>
@@ -5216,7 +5270,7 @@
       </p:sp>
       <p:sp>
         <p:nvSpPr>
-          <p:cNvPr id="20" name="TextBox 19"/>
+          <p:cNvPr id="21" name="TextBox 20"/>
           <p:cNvSpPr txBox="1"/>
           <p:nvPr/>
         </p:nvSpPr>
@@ -5305,7 +5359,7 @@
       </p:sp>
       <p:sp>
         <p:nvSpPr>
-          <p:cNvPr id="21" name="Rectangle 20"/>
+          <p:cNvPr id="22" name="Rectangle 21"/>
           <p:cNvSpPr/>
           <p:nvPr/>
         </p:nvSpPr>
@@ -5349,7 +5403,7 @@
       </p:sp>
       <p:sp>
         <p:nvSpPr>
-          <p:cNvPr id="22" name="TextBox 21"/>
+          <p:cNvPr id="23" name="TextBox 22"/>
           <p:cNvSpPr txBox="1"/>
           <p:nvPr/>
         </p:nvSpPr>
@@ -11704,7 +11758,7 @@
                 </a:solidFill>
                 <a:latin typeface="Arial"/>
               </a:rPr>
-              <a:t>Hoy: un CV anonimizado por correo → teaser con tu branding esta semana (entorno con DPA).</a:t>
+              <a:t>Hoy: CV anonimizado + tu fee por WhatsApp → teaser branded + registro anti-duplicado en vivo esta semana.</a:t>
             </a:r>
           </a:p>
         </p:txBody>

</xml_diff>

<commit_message>
Consejo LLM #04 + iteración 4: mecánica del cierre + auto-corrección
- (alta) Nueva §11 Orden de servicio de 1 página (firmable): alcance, $2.500, 50% anticipo,
  garantía, validez. Instrumento de cierre que faltaba.
- (alta) Garantía de devolución del anticipo si no ve valor; nota de continuidad (no depende de 1 persona).
- (media) Puerta 0 con vara de negocio; ROI pre-llenado sin tarea (revierte exceso de iter 3);
  plan B del tangible (CV sintético); gantt honesto con apoyo puntual.
- Nombre de la firma: pendiente de elección de Víctor (3 sugerencias). PDF 18pp + deck 19 slides.

Co-Authored-By: Claude Opus 4.8 <noreply@anthropic.com>
</commit_message>
<xml_diff>
--- a/04-propuesta/Presentacion-Conexion-Talento.pptx
+++ b/04-propuesta/Presentacion-Conexion-Talento.pptx
@@ -4210,7 +4210,7 @@
                 </a:solidFill>
                 <a:latin typeface="Arial"/>
               </a:rPr>
-              <a:t>todavía no tengo tu fee promedio ni cuántos mandatos manejas al mes. Mándamelos HOY por WhatsApp y traigo tu ROI con tu número real al viernes —no un ejemplo—.</a:t>
+              <a:t>el ejemplo usa un fee conservador supuesto —prudente, no inflado—. El caso ya se sostiene; si me pasas tu fee real cuando puedas, lo afino. No es tarea para hoy.</a:t>
             </a:r>
           </a:p>
           <a:p>
@@ -4671,7 +4671,7 @@
                 </a:solidFill>
                 <a:latin typeface="Arial"/>
               </a:rPr>
-              <a:t>Tu seguro: los activos tangibles son tuyos aunque la Puerta 0 salga roja y no continúes.</a:t>
+              <a:t>Tu seguro: te quedas los activos y, si no ves valor, te devolvemos el anticipo. El riesgo es nuestro.</a:t>
             </a:r>
           </a:p>
         </p:txBody>
@@ -8612,7 +8612,7 @@
                 </a:solidFill>
                 <a:latin typeface="Arial"/>
               </a:rPr>
-              <a:t>Las fases se solapan: la extracción de datos corre en paralelo a la documentación.</a:t>
+              <a:t>Las fases se solapan poco y con apoyo puntual donde se requiere — no depende de una sola persona.</a:t>
             </a:r>
           </a:p>
           <a:p>
@@ -11624,7 +11624,7 @@
                 </a:solidFill>
                 <a:latin typeface="Arial"/>
               </a:rPr>
-              <a:t>Aprobar la Fase 0 (US$2.500) — tu decisión de hoy.</a:t>
+              <a:t>Firmar la orden de la Fase 0 (1 página): US$2.500, 50% de anticipo — tu decisión de hoy.</a:t>
             </a:r>
           </a:p>
         </p:txBody>
@@ -11758,7 +11758,7 @@
                 </a:solidFill>
                 <a:latin typeface="Arial"/>
               </a:rPr>
-              <a:t>Hoy: CV anonimizado + tu fee por WhatsApp → teaser branded + registro anti-duplicado en vivo esta semana.</a:t>
+              <a:t>Esta semana: CV anonimizado (o sintético) → teaser branded + registro anti-duplicado en vivo, con DPA.</a:t>
             </a:r>
           </a:p>
         </p:txBody>
@@ -11892,7 +11892,7 @@
                 </a:solidFill>
                 <a:latin typeface="Arial"/>
               </a:rPr>
-              <a:t>Lunes: acceso a Team Tailor + abogado/a. Demo completa + semáforo en 2–3 semanas.</a:t>
+              <a:t>Lunes: acceso a Team Tailor + abogado/a. Demo + semáforo en 2–3 semanas.</a:t>
             </a:r>
           </a:p>
         </p:txBody>

</xml_diff>

<commit_message>
Consejo LLM #05 + iteración 5: integridad económica/legal final — LOOP COMPLETO (5/5)
- (alta) Des-apilar el 'put gratis' (garantía objetiva atada a Puerta 0); caveat demanda-vs-oferta
  en el ROI; entorno DPA asignado a Víctor el lunes; consentimiento prospectivo desde F1.
- (media) Vara (a) de Puerta 0 condicionada al export; Fase 0 renombrada 'Quick Wins + prueba de
  valor'; encuadre de la demo (discrepancia = insumo de la F1).
- PDF 19pp + deck 19 slides. Bitácora 01d + loop-consejo-estado cierran el ciclo.
- Pendiente único: nombre de la firma (reemplazar placeholder).

Co-Authored-By: Claude Opus 4.8 <noreply@anthropic.com>
</commit_message>
<xml_diff>
--- a/04-propuesta/Presentacion-Conexion-Talento.pptx
+++ b/04-propuesta/Presentacion-Conexion-Talento.pptx
@@ -4250,7 +4250,7 @@
                 </a:solidFill>
                 <a:latin typeface="Arial"/>
               </a:rPr>
-              <a:t>la velocidad te pone primera en la fila; el cierre sigue dependiendo de tu ojo y del cliente. Buscamos ponerte primera en la fila — no prometemos colocaciones.</a:t>
+              <a:t>aplica solo si hoy pierdes mandatos por velocidad —no si tienes capacidad ociosa—; esa es la primera pregunta del martes. La velocidad te pone primera en la fila; no prometemos colocaciones.</a:t>
             </a:r>
           </a:p>
         </p:txBody>
@@ -4649,7 +4649,7 @@
                 </a:solidFill>
                 <a:latin typeface="Arial"/>
               </a:rPr>
-              <a:t>Factibilidad pagada + 2 quick wins · 2–3 semanas · 100% acreditable a la siguiente fase</a:t>
+              <a:t>Quick wins + prueba de valor con tus datos · 2–3 semanas · 100% acreditable a la Fase 1</a:t>
             </a:r>
           </a:p>
           <a:p>
@@ -4671,7 +4671,7 @@
                 </a:solidFill>
                 <a:latin typeface="Arial"/>
               </a:rPr>
-              <a:t>Tu seguro: te quedas los activos y, si no ves valor, te devolvemos el anticipo. El riesgo es nuestro.</a:t>
+              <a:t>Tu seguro: te quedas los activos; avanzas a la Fase 1 solo si la Puerta 0 pasa su vara objetiva. Sin letra chica.</a:t>
             </a:r>
           </a:p>
         </p:txBody>
@@ -6582,7 +6582,7 @@
                           </a:solidFill>
                           <a:latin typeface="Arial"/>
                         </a:rPr>
-                        <a:t>Factibilidad + Quick Wins</a:t>
+                        <a:t>Quick Wins + prueba de valor</a:t>
                       </a:r>
                     </a:p>
                   </a:txBody>
@@ -6670,7 +6670,7 @@
                           </a:solidFill>
                           <a:latin typeface="Arial"/>
                         </a:rPr>
-                        <a:t>Empezamos aquí: semáforo + 2 quick wins</a:t>
+                        <a:t>Empezamos aquí: 2 quick wins + semáforo</a:t>
                       </a:r>
                     </a:p>
                   </a:txBody>
@@ -16812,7 +16812,7 @@
                 </a:solidFill>
                 <a:latin typeface="Arial"/>
               </a:rPr>
-              <a:t>Factibilidad + 2 quick wins visibles</a:t>
+              <a:t>Quick wins + prueba de valor con tus datos</a:t>
             </a:r>
           </a:p>
           <a:p>

</xml_diff>

<commit_message>
Consejo LLM #06 (2a tanda): alivio inmediato + protocolo de la garantía
- (alta) Auditoría exprés de Team Tailor sobre vacante viva en sem 1 = horas de vuelta con mano
  de Víctor (no de la temporal); desarma la objeción del CFO. Era nota filosófica, ahora entregable.
- (alta) Protocolo de medición de la garantía objetiva: baseline + reloj de pared + misma vacante,
  aislado de la temporal (que contaminaba el test 'proceso, no manos').
- (media) 'Competidor' en sentido estrecho en la cláusula de IP (interna).
- Umbral alto: solo 3 mejoras sustantivas, sin nitpicks. PDF 19pp + deck 19 slides.

Co-Authored-By: Claude Opus 4.8 <noreply@anthropic.com>
</commit_message>
<xml_diff>
--- a/04-propuesta/Presentacion-Conexion-Talento.pptx
+++ b/04-propuesta/Presentacion-Conexion-Talento.pptx
@@ -17443,8 +17443,8 @@
         </p:nvSpPr>
         <p:spPr>
           <a:xfrm>
-            <a:off x="640080" y="2240280"/>
-            <a:ext cx="457200" cy="457200"/>
+            <a:off x="640080" y="2121408"/>
+            <a:ext cx="420624" cy="420624"/>
           </a:xfrm>
           <a:prstGeom prst="rect">
             <a:avLst/>
@@ -17487,8 +17487,8 @@
         </p:nvSpPr>
         <p:spPr>
           <a:xfrm>
-            <a:off x="640080" y="2240280"/>
-            <a:ext cx="457200" cy="457200"/>
+            <a:off x="640080" y="2121408"/>
+            <a:ext cx="420624" cy="420624"/>
           </a:xfrm>
           <a:prstGeom prst="rect">
             <a:avLst/>
@@ -17513,7 +17513,7 @@
               </a:spcAft>
             </a:pPr>
             <a:r>
-              <a:rPr sz="1800" b="1">
+              <a:rPr sz="1600" b="1">
                 <a:solidFill>
                   <a:srgbClr val="FFFFFF"/>
                 </a:solidFill>
@@ -17532,8 +17532,8 @@
         </p:nvSpPr>
         <p:spPr>
           <a:xfrm>
-            <a:off x="1325880" y="2240280"/>
-            <a:ext cx="10058400" cy="868680"/>
+            <a:off x="1280160" y="2121408"/>
+            <a:ext cx="10149840" cy="786384"/>
           </a:xfrm>
           <a:prstGeom prst="rect">
             <a:avLst/>
@@ -17548,7 +17548,7 @@
           <a:p>
             <a:pPr algn="l">
               <a:lnSpc>
-                <a:spcPct val="118000"/>
+                <a:spcPct val="115000"/>
               </a:lnSpc>
               <a:spcBef>
                 <a:spcPts val="0"/>
@@ -17558,22 +17558,22 @@
               </a:spcAft>
             </a:pPr>
             <a:r>
-              <a:rPr sz="1500" b="1">
+              <a:rPr sz="1450" b="1">
                 <a:solidFill>
                   <a:srgbClr val="102A43"/>
                 </a:solidFill>
                 <a:latin typeface="Arial"/>
               </a:rPr>
-              <a:t>La IA trabajando con tus datos:  </a:t>
-            </a:r>
-            <a:r>
-              <a:rPr sz="1500" b="0">
+              <a:t>Horas de vuelta esta semana:  </a:t>
+            </a:r>
+            <a:r>
+              <a:rPr sz="1450" b="0">
                 <a:solidFill>
                   <a:srgbClr val="1A2733"/>
                 </a:solidFill>
                 <a:latin typeface="Arial"/>
               </a:rPr>
-              <a:t>20–30 CVs reales de una vacante tuya abierta, ordenados con tu criterio replicado — en un entorno con DPA, cumpliendo desde el día 1.</a:t>
+              <a:t>activamos la IA que Team Tailor ya cobra, sobre una vacante viva — alivio inmediato, con nuestra mano (no la de la temporal).</a:t>
             </a:r>
           </a:p>
         </p:txBody>
@@ -17586,8 +17586,8 @@
         </p:nvSpPr>
         <p:spPr>
           <a:xfrm>
-            <a:off x="640080" y="3136392"/>
-            <a:ext cx="457200" cy="457200"/>
+            <a:off x="640080" y="2944368"/>
+            <a:ext cx="420624" cy="420624"/>
           </a:xfrm>
           <a:prstGeom prst="rect">
             <a:avLst/>
@@ -17630,8 +17630,8 @@
         </p:nvSpPr>
         <p:spPr>
           <a:xfrm>
-            <a:off x="640080" y="3136392"/>
-            <a:ext cx="457200" cy="457200"/>
+            <a:off x="640080" y="2944368"/>
+            <a:ext cx="420624" cy="420624"/>
           </a:xfrm>
           <a:prstGeom prst="rect">
             <a:avLst/>
@@ -17656,7 +17656,7 @@
               </a:spcAft>
             </a:pPr>
             <a:r>
-              <a:rPr sz="1800" b="1">
+              <a:rPr sz="1600" b="1">
                 <a:solidFill>
                   <a:srgbClr val="FFFFFF"/>
                 </a:solidFill>
@@ -17675,8 +17675,8 @@
         </p:nvSpPr>
         <p:spPr>
           <a:xfrm>
-            <a:off x="1325880" y="3136392"/>
-            <a:ext cx="10058400" cy="868680"/>
+            <a:off x="1280160" y="2944368"/>
+            <a:ext cx="10149840" cy="786384"/>
           </a:xfrm>
           <a:prstGeom prst="rect">
             <a:avLst/>
@@ -17691,7 +17691,7 @@
           <a:p>
             <a:pPr algn="l">
               <a:lnSpc>
-                <a:spcPct val="118000"/>
+                <a:spcPct val="115000"/>
               </a:lnSpc>
               <a:spcBef>
                 <a:spcPts val="0"/>
@@ -17701,22 +17701,22 @@
               </a:spcAft>
             </a:pPr>
             <a:r>
-              <a:rPr sz="1500" b="1">
+              <a:rPr sz="1450" b="1">
                 <a:solidFill>
                   <a:srgbClr val="102A43"/>
                 </a:solidFill>
                 <a:latin typeface="Arial"/>
               </a:rPr>
-              <a:t>Tu CV con el sello de la firma:  </a:t>
-            </a:r>
-            <a:r>
-              <a:rPr sz="1500" b="0">
+              <a:t>La IA trabajando con tus datos:  </a:t>
+            </a:r>
+            <a:r>
+              <a:rPr sz="1450" b="0">
                 <a:solidFill>
                   <a:srgbClr val="1A2733"/>
                 </a:solidFill>
                 <a:latin typeface="Arial"/>
               </a:rPr>
-              <a:t>plantilla única, ya montada sobre un candidato real.</a:t>
+              <a:t>20–30 CVs reales ordenados con tu criterio replicado — en un entorno con DPA, cumpliendo desde el día 1.</a:t>
             </a:r>
           </a:p>
         </p:txBody>
@@ -17729,8 +17729,8 @@
         </p:nvSpPr>
         <p:spPr>
           <a:xfrm>
-            <a:off x="640080" y="4032504"/>
-            <a:ext cx="457200" cy="457200"/>
+            <a:off x="640080" y="3767328"/>
+            <a:ext cx="420624" cy="420624"/>
           </a:xfrm>
           <a:prstGeom prst="rect">
             <a:avLst/>
@@ -17773,8 +17773,8 @@
         </p:nvSpPr>
         <p:spPr>
           <a:xfrm>
-            <a:off x="640080" y="4032504"/>
-            <a:ext cx="457200" cy="457200"/>
+            <a:off x="640080" y="3767328"/>
+            <a:ext cx="420624" cy="420624"/>
           </a:xfrm>
           <a:prstGeom prst="rect">
             <a:avLst/>
@@ -17799,7 +17799,7 @@
               </a:spcAft>
             </a:pPr>
             <a:r>
-              <a:rPr sz="1800" b="1">
+              <a:rPr sz="1600" b="1">
                 <a:solidFill>
                   <a:srgbClr val="FFFFFF"/>
                 </a:solidFill>
@@ -17818,8 +17818,8 @@
         </p:nvSpPr>
         <p:spPr>
           <a:xfrm>
-            <a:off x="1325880" y="4032504"/>
-            <a:ext cx="10058400" cy="868680"/>
+            <a:off x="1280160" y="3767328"/>
+            <a:ext cx="10149840" cy="786384"/>
           </a:xfrm>
           <a:prstGeom prst="rect">
             <a:avLst/>
@@ -17834,7 +17834,7 @@
           <a:p>
             <a:pPr algn="l">
               <a:lnSpc>
-                <a:spcPct val="118000"/>
+                <a:spcPct val="115000"/>
               </a:lnSpc>
               <a:spcBef>
                 <a:spcPts val="0"/>
@@ -17844,22 +17844,22 @@
               </a:spcAft>
             </a:pPr>
             <a:r>
-              <a:rPr sz="1500" b="1">
+              <a:rPr sz="1450" b="1">
                 <a:solidFill>
                   <a:srgbClr val="102A43"/>
                 </a:solidFill>
                 <a:latin typeface="Arial"/>
               </a:rPr>
-              <a:t>Registro anti-duplicado funcionando:  </a:t>
-            </a:r>
-            <a:r>
-              <a:rPr sz="1500" b="0">
+              <a:t>Tu CV con el sello de la firma:  </a:t>
+            </a:r>
+            <a:r>
+              <a:rPr sz="1450" b="0">
                 <a:solidFill>
                   <a:srgbClr val="1A2733"/>
                 </a:solidFill>
                 <a:latin typeface="Arial"/>
               </a:rPr>
-              <a:t>se acaba el bochorno de presentar dos veces al mismo candidato.</a:t>
+              <a:t>plantilla única, ya montada sobre un candidato real.</a:t>
             </a:r>
           </a:p>
         </p:txBody>
@@ -17872,8 +17872,8 @@
         </p:nvSpPr>
         <p:spPr>
           <a:xfrm>
-            <a:off x="640080" y="4928616"/>
-            <a:ext cx="457200" cy="457200"/>
+            <a:off x="640080" y="4590288"/>
+            <a:ext cx="420624" cy="420624"/>
           </a:xfrm>
           <a:prstGeom prst="rect">
             <a:avLst/>
@@ -17916,8 +17916,8 @@
         </p:nvSpPr>
         <p:spPr>
           <a:xfrm>
-            <a:off x="640080" y="4928616"/>
-            <a:ext cx="457200" cy="457200"/>
+            <a:off x="640080" y="4590288"/>
+            <a:ext cx="420624" cy="420624"/>
           </a:xfrm>
           <a:prstGeom prst="rect">
             <a:avLst/>
@@ -17942,7 +17942,7 @@
               </a:spcAft>
             </a:pPr>
             <a:r>
-              <a:rPr sz="1800" b="1">
+              <a:rPr sz="1600" b="1">
                 <a:solidFill>
                   <a:srgbClr val="FFFFFF"/>
                 </a:solidFill>
@@ -17961,8 +17961,8 @@
         </p:nvSpPr>
         <p:spPr>
           <a:xfrm>
-            <a:off x="1325880" y="4928616"/>
-            <a:ext cx="10058400" cy="868680"/>
+            <a:off x="1280160" y="4590288"/>
+            <a:ext cx="10149840" cy="786384"/>
           </a:xfrm>
           <a:prstGeom prst="rect">
             <a:avLst/>
@@ -17977,7 +17977,7 @@
           <a:p>
             <a:pPr algn="l">
               <a:lnSpc>
-                <a:spcPct val="118000"/>
+                <a:spcPct val="115000"/>
               </a:lnSpc>
               <a:spcBef>
                 <a:spcPts val="0"/>
@@ -17987,16 +17987,159 @@
               </a:spcAft>
             </a:pPr>
             <a:r>
-              <a:rPr sz="1500" b="1">
+              <a:rPr sz="1450" b="1">
                 <a:solidFill>
                   <a:srgbClr val="102A43"/>
                 </a:solidFill>
                 <a:latin typeface="Arial"/>
               </a:rPr>
+              <a:t>Registro anti-duplicado funcionando:  </a:t>
+            </a:r>
+            <a:r>
+              <a:rPr sz="1450" b="0">
+                <a:solidFill>
+                  <a:srgbClr val="1A2733"/>
+                </a:solidFill>
+                <a:latin typeface="Arial"/>
+              </a:rPr>
+              <a:t>se acaba el bochorno de presentar dos veces al mismo candidato.</a:t>
+            </a:r>
+          </a:p>
+        </p:txBody>
+      </p:sp>
+      <p:sp>
+        <p:nvSpPr>
+          <p:cNvPr id="20" name="Rectangle 19"/>
+          <p:cNvSpPr/>
+          <p:nvPr/>
+        </p:nvSpPr>
+        <p:spPr>
+          <a:xfrm>
+            <a:off x="640080" y="5413248"/>
+            <a:ext cx="420624" cy="420624"/>
+          </a:xfrm>
+          <a:prstGeom prst="rect">
+            <a:avLst/>
+          </a:prstGeom>
+          <a:solidFill>
+            <a:srgbClr val="1C7C8C"/>
+          </a:solidFill>
+          <a:ln>
+            <a:noFill/>
+          </a:ln>
+          <a:effectLst/>
+        </p:spPr>
+        <p:style>
+          <a:lnRef idx="1">
+            <a:schemeClr val="accent1"/>
+          </a:lnRef>
+          <a:fillRef idx="3">
+            <a:schemeClr val="accent1"/>
+          </a:fillRef>
+          <a:effectRef idx="2">
+            <a:schemeClr val="accent1"/>
+          </a:effectRef>
+          <a:fontRef idx="minor">
+            <a:schemeClr val="lt1"/>
+          </a:fontRef>
+        </p:style>
+        <p:txBody>
+          <a:bodyPr rtlCol="0" anchor="ctr"/>
+          <a:lstStyle/>
+          <a:p>
+            <a:pPr algn="ctr"/>
+          </a:p>
+        </p:txBody>
+      </p:sp>
+      <p:sp>
+        <p:nvSpPr>
+          <p:cNvPr id="21" name="TextBox 20"/>
+          <p:cNvSpPr txBox="1"/>
+          <p:nvPr/>
+        </p:nvSpPr>
+        <p:spPr>
+          <a:xfrm>
+            <a:off x="640080" y="5413248"/>
+            <a:ext cx="420624" cy="420624"/>
+          </a:xfrm>
+          <a:prstGeom prst="rect">
+            <a:avLst/>
+          </a:prstGeom>
+          <a:noFill/>
+        </p:spPr>
+        <p:txBody>
+          <a:bodyPr wrap="square" anchor="ctr" lIns="0" rIns="0" tIns="0" bIns="0">
+            <a:spAutoFit/>
+          </a:bodyPr>
+          <a:lstStyle/>
+          <a:p>
+            <a:pPr algn="ctr">
+              <a:lnSpc>
+                <a:spcPct val="108000"/>
+              </a:lnSpc>
+              <a:spcBef>
+                <a:spcPts val="0"/>
+              </a:spcBef>
+              <a:spcAft>
+                <a:spcPts val="400"/>
+              </a:spcAft>
+            </a:pPr>
+            <a:r>
+              <a:rPr sz="1600" b="1">
+                <a:solidFill>
+                  <a:srgbClr val="FFFFFF"/>
+                </a:solidFill>
+                <a:latin typeface="Arial"/>
+              </a:rPr>
+              <a:t>✓</a:t>
+            </a:r>
+          </a:p>
+        </p:txBody>
+      </p:sp>
+      <p:sp>
+        <p:nvSpPr>
+          <p:cNvPr id="22" name="TextBox 21"/>
+          <p:cNvSpPr txBox="1"/>
+          <p:nvPr/>
+        </p:nvSpPr>
+        <p:spPr>
+          <a:xfrm>
+            <a:off x="1280160" y="5413248"/>
+            <a:ext cx="10149840" cy="786384"/>
+          </a:xfrm>
+          <a:prstGeom prst="rect">
+            <a:avLst/>
+          </a:prstGeom>
+          <a:noFill/>
+        </p:spPr>
+        <p:txBody>
+          <a:bodyPr wrap="square" anchor="ctr" lIns="0" rIns="0" tIns="0" bIns="0">
+            <a:spAutoFit/>
+          </a:bodyPr>
+          <a:lstStyle/>
+          <a:p>
+            <a:pPr algn="l">
+              <a:lnSpc>
+                <a:spcPct val="115000"/>
+              </a:lnSpc>
+              <a:spcBef>
+                <a:spcPts val="0"/>
+              </a:spcBef>
+              <a:spcAft>
+                <a:spcPts val="400"/>
+              </a:spcAft>
+            </a:pPr>
+            <a:r>
+              <a:rPr sz="1450" b="1">
+                <a:solidFill>
+                  <a:srgbClr val="102A43"/>
+                </a:solidFill>
+                <a:latin typeface="Arial"/>
+              </a:rPr>
               <a:t>El semáforo honesto:  </a:t>
             </a:r>
             <a:r>
-              <a:rPr sz="1500" b="0">
+              <a:rPr sz="1450" b="0">
                 <a:solidFill>
                   <a:srgbClr val="1A2733"/>
                 </a:solidFill>

</xml_diff>

<commit_message>
Lenguaje ejecutivo: todo el proyecto comunicado en términos de negocio
- 16 docs de trabajo reescritos a lenguaje ejecutivo (workflow + verificación por pares):
  README, descubrimiento, solución, roadmap, investigación, propuesta interna. Jerga traducida,
  resúmenes ejecutivos, TODAS las cifras/⚠️/fuentes preservadas.
- Doc cliente (PDF) y deck: ~95 términos técnicos traducidos quirúrgicamente (ATS, API, golden set,
  RoPA, RACI, North Star, k-anonimato, ESCO, time-to-terna, fixed-fee, retainer, etc.), cifras y
  estructura intactas. PDF 19pp + deck 19 slides re-renderizados y verificados.
- Iteración 7 del consejo: corregido 'el martes' colgado (→ 'nuestra primera sesión'); añadido que
  la capacidad ociosa REORDENA el programa; Plan B comercial si la Puerta 0 sale roja (interna §11.6).
- Precisión: 'competencia desleal' → 'prácticas anticompetitivas'; '63% = concentración', no 'gana bien'.

Co-Authored-By: Claude Opus 4.8 <noreply@anthropic.com>
</commit_message>
<xml_diff>
--- a/04-propuesta/Presentacion-Conexion-Talento.pptx
+++ b/04-propuesta/Presentacion-Conexion-Talento.pptx
@@ -4250,7 +4250,7 @@
                 </a:solidFill>
                 <a:latin typeface="Arial"/>
               </a:rPr>
-              <a:t>aplica solo si hoy pierdes mandatos por velocidad —no si tienes capacidad ociosa—; esa es la primera pregunta del martes. La velocidad te pone primera en la fila; no prometemos colocaciones.</a:t>
+              <a:t>aplica solo si hoy pierdes mandatos por velocidad —no si tienes capacidad ociosa—; esa es la primera pregunta de nuestra primera sesión. La velocidad te pone primera en la fila; no prometemos colocaciones.</a:t>
             </a:r>
           </a:p>
         </p:txBody>
@@ -4649,7 +4649,7 @@
                 </a:solidFill>
                 <a:latin typeface="Arial"/>
               </a:rPr>
-              <a:t>Quick wins + prueba de valor con tus datos · 2–3 semanas · 100% acreditable a la Fase 1</a:t>
+              <a:t>Victorias rápidas + prueba de valor con tus datos · 2–3 semanas · 100% acreditable a la Fase 1</a:t>
             </a:r>
           </a:p>
           <a:p>
@@ -5450,7 +5450,7 @@
                 </a:solidFill>
                 <a:latin typeface="Arial"/>
               </a:rPr>
-              <a:t>precio cerrado por fase — pagas solo lo que apruebas en cada puerta. Sin retainer ni cobro por “éxito” al inicio: no hay aún línea base para medirlo de forma justa.</a:t>
+              <a:t>precio cerrado por fase — pagas solo lo que apruebas en cada puerta. Sin cuota fija mensual ni cobro por “éxito” al inicio: no hay aún línea base para medirlo de forma justa.</a:t>
             </a:r>
           </a:p>
         </p:txBody>
@@ -5824,7 +5824,7 @@
                           </a:solidFill>
                           <a:latin typeface="Arial"/>
                         </a:rPr>
-                        <a:t>Vender el benchmark salarial = bandera roja</a:t>
+                        <a:t>Vender el comparativo salarial de mercado = bandera roja</a:t>
                       </a:r>
                     </a:p>
                   </a:txBody>
@@ -5846,7 +5846,7 @@
                           </a:solidFill>
                           <a:latin typeface="Arial"/>
                         </a:rPr>
-                        <a:t>Congelado hasta dictamen de abogado salvadoreño + anonimización irreversible (k-anonimato)</a:t>
+                        <a:t>Congelado hasta dictamen de abogado salvadoreño + anonimización irreversible</a:t>
                       </a:r>
                     </a:p>
                   </a:txBody>
@@ -5870,7 +5870,7 @@
                           </a:solidFill>
                           <a:latin typeface="Arial"/>
                         </a:rPr>
-                        <a:t>Sesgo en cribado automático</a:t>
+                        <a:t>Sesgo en el filtrado automático</a:t>
                       </a:r>
                     </a:p>
                   </a:txBody>
@@ -5892,7 +5892,7 @@
                           </a:solidFill>
                           <a:latin typeface="Arial"/>
                         </a:rPr>
-                        <a:t>Humano-en-el-bucle obligatorio; la IA nunca rechaza sola; auditoría de sesgo y trazabilidad</a:t>
+                        <a:t>Una persona validando siempre (obligatorio); la IA nunca rechaza sola; auditoría de sesgo y trazabilidad</a:t>
                       </a:r>
                     </a:p>
                   </a:txBody>
@@ -5916,7 +5916,7 @@
                           </a:solidFill>
                           <a:latin typeface="Arial"/>
                         </a:rPr>
-                        <a:t>API de Team Tailor no verificada</a:t>
+                        <a:t>Conexión técnica con Team Tailor no verificada</a:t>
                       </a:r>
                     </a:p>
                   </a:txBody>
@@ -5938,7 +5938,7 @@
                           </a:solidFill>
                           <a:latin typeface="Arial"/>
                         </a:rPr>
-                        <a:t>Spike de factibilidad en la Fase 0 (semana 1); plan B de captura acotada</a:t>
+                        <a:t>Prueba de factibilidad en la Fase 0 (semana 1); plan B de captura acotada</a:t>
                       </a:r>
                     </a:p>
                   </a:txBody>
@@ -5984,7 +5984,7 @@
                           </a:solidFill>
                           <a:latin typeface="Arial"/>
                         </a:rPr>
-                        <a:t>R&amp;S opera en SV+GT. GT aún sin ley general; transferencia con DPA y minimización. El estándar se construye una vez y se despliega en ambos países</a:t>
+                        <a:t>Reclutamiento y Selección opera en SV+GT. GT aún sin ley general; transferencia con acuerdo de protección de datos y minimización de datos. El estándar se construye una vez y se despliega en ambos países</a:t>
                       </a:r>
                     </a:p>
                   </a:txBody>
@@ -6582,7 +6582,7 @@
                           </a:solidFill>
                           <a:latin typeface="Arial"/>
                         </a:rPr>
-                        <a:t>Quick Wins + prueba de valor</a:t>
+                        <a:t>Victorias rápidas + prueba de valor</a:t>
                       </a:r>
                     </a:p>
                   </a:txBody>
@@ -6670,7 +6670,7 @@
                           </a:solidFill>
                           <a:latin typeface="Arial"/>
                         </a:rPr>
-                        <a:t>Empezamos aquí: 2 quick wins + semáforo</a:t>
+                        <a:t>Empezamos aquí: 2 victorias rápidas + semáforo</a:t>
                       </a:r>
                     </a:p>
                   </a:txBody>
@@ -6804,7 +6804,7 @@
                           </a:solidFill>
                           <a:latin typeface="Arial"/>
                         </a:rPr>
-                        <a:t>La “columna vertebral”: SOPs, rúbrica, métricas</a:t>
+                        <a:t>La “columna vertebral”: manuales de proceso, guía de puntuación, métricas</a:t>
                       </a:r>
                     </a:p>
                   </a:txBody>
@@ -6938,7 +6938,7 @@
                           </a:solidFill>
                           <a:latin typeface="Arial"/>
                         </a:rPr>
-                        <a:t>Screener/Ranker + Generador de CV (con HITL)</a:t>
+                        <a:t>Asistente que ordena candidatos + Generador de CV (con una persona validando)</a:t>
                       </a:r>
                     </a:p>
                   </a:txBody>
@@ -7051,7 +7051,7 @@
                           <a:latin typeface="Arial"/>
                         </a:rPr>
                         <a:t>desde 15.000 /
-retainer 3.500/mes</a:t>
+cuota fija 3.500/mes</a:t>
                       </a:r>
                     </a:p>
                   </a:txBody>
@@ -7073,7 +7073,7 @@
                           </a:solidFill>
                           <a:latin typeface="Arial"/>
                         </a:rPr>
-                        <a:t>Base buscable, mercado interno, benchmark</a:t>
+                        <a:t>Base buscable, mercado interno, comparativo salarial</a:t>
                       </a:r>
                     </a:p>
                   </a:txBody>
@@ -8643,7 +8643,7 @@
                 </a:solidFill>
                 <a:latin typeface="Arial"/>
               </a:rPr>
-              <a:t>Cada puerta go/no-go es una decisión explícita de continuar, reordenar o detener.</a:t>
+              <a:t>Cada puerta es una decisión explícita de continuar, reordenar o detener.</a:t>
             </a:r>
           </a:p>
         </p:txBody>
@@ -9158,7 +9158,7 @@
                 </a:solidFill>
                 <a:latin typeface="Arial"/>
               </a:rPr>
-              <a:t>los 8 pasos con RACI, SLA por etapa y dueño nombrado</a:t>
+              <a:t>los 8 pasos con quién hace qué, compromiso de tiempo de respuesta por etapa y dueño nombrado</a:t>
             </a:r>
           </a:p>
           <a:p>
@@ -9189,7 +9189,7 @@
                 </a:solidFill>
                 <a:latin typeface="Arial"/>
               </a:rPr>
-              <a:t>SOP de cribado + rúbrica + golden set: </a:t>
+              <a:t>Manual de filtrado + guía de puntuación + set de decisiones de referencia: </a:t>
             </a:r>
             <a:r>
               <a:rPr sz="1250" b="0">
@@ -9229,7 +9229,7 @@
                 </a:solidFill>
                 <a:latin typeface="Arial"/>
               </a:rPr>
-              <a:t>Scorecard de intake: </a:t>
+              <a:t>Hoja de criterios de la vacante: </a:t>
             </a:r>
             <a:r>
               <a:rPr sz="1250" b="0">
@@ -9238,7 +9238,7 @@
                 </a:solidFill>
                 <a:latin typeface="Arial"/>
               </a:rPr>
-              <a:t>1 página por vacante: must/nice-to-have, pesos, éxito a 90 días</a:t>
+              <a:t>1 página por vacante: imprescindibles/deseables, pesos, éxito a 90 días</a:t>
             </a:r>
           </a:p>
           <a:p>
@@ -9269,7 +9269,7 @@
                 </a:solidFill>
                 <a:latin typeface="Arial"/>
               </a:rPr>
-              <a:t>Árbol de métricas + estandarización del ATS: </a:t>
+              <a:t>Árbol de métricas + estandarización de tu sistema de candidatos (Team Tailor): </a:t>
             </a:r>
             <a:r>
               <a:rPr sz="1250" b="0">
@@ -9278,7 +9278,7 @@
                 </a:solidFill>
                 <a:latin typeface="Arial"/>
               </a:rPr>
-              <a:t>1 North Star + ~10 KPIs; etapas y campos obligatorios</a:t>
+              <a:t>1 métrica guía + ~10 indicadores; etapas y campos obligatorios</a:t>
             </a:r>
           </a:p>
           <a:p>
@@ -9309,7 +9309,7 @@
                 </a:solidFill>
                 <a:latin typeface="Arial"/>
               </a:rPr>
-              <a:t>Gobernanza de datos + taxonomía v1: </a:t>
+              <a:t>Gobernanza de datos + clasificación v1: </a:t>
             </a:r>
             <a:r>
               <a:rPr sz="1250" b="0">
@@ -9318,7 +9318,7 @@
                 </a:solidFill>
                 <a:latin typeface="Arial"/>
               </a:rPr>
-              <a:t>RoPA-lite, base legal por finalidad, diccionario de skills</a:t>
+              <a:t>registro de datos que pide la ley (versión ligera), base legal por finalidad, diccionario de competencias</a:t>
             </a:r>
           </a:p>
         </p:txBody>
@@ -9462,7 +9462,7 @@
                 </a:solidFill>
                 <a:latin typeface="Arial"/>
               </a:rPr>
-              <a:t>etapas estandarizadas; SOP + rúbrica firmados; golden set armado; baseline medido. La IA no arranca sin esto.</a:t>
+              <a:t>etapas estandarizadas; manual y guía de puntuación firmados; set de decisiones de referencia armado; línea base medida. La IA no arranca sin esto.</a:t>
             </a:r>
           </a:p>
         </p:txBody>
@@ -9968,7 +9968,7 @@
                 </a:solidFill>
                 <a:latin typeface="Arial"/>
               </a:rPr>
-              <a:t>Screener/Ranker asistido (~US$7.000): </a:t>
+              <a:t>Asistente que ordena candidatos (~US$7.000): </a:t>
             </a:r>
             <a:r>
               <a:rPr sz="1250" b="0">
@@ -9977,7 +9977,7 @@
                 </a:solidFill>
                 <a:latin typeface="Arial"/>
               </a:rPr>
-              <a:t>des-identifica PII → puntúa vs scorecard con justificación → pre-ordena. El humano valida; la IA nunca rechaza sola</a:t>
+              <a:t>quita los datos personales → puntúa contra la hoja de criterios con justificación → pre-ordena. El humano valida; la IA nunca rechaza sola</a:t>
             </a:r>
           </a:p>
           <a:p>
@@ -10008,7 +10008,7 @@
                 </a:solidFill>
                 <a:latin typeface="Arial"/>
               </a:rPr>
-              <a:t>Generador de CV con branding (~US$4.000): </a:t>
+              <a:t>Generador de CV con tu marca (~US$4.000): </a:t>
             </a:r>
             <a:r>
               <a:rPr sz="1250" b="0">
@@ -10017,7 +10017,7 @@
                 </a:solidFill>
                 <a:latin typeface="Arial"/>
               </a:rPr>
-              <a:t>extracción a esquema fijo + plantilla determinista</a:t>
+              <a:t>lectura automática a un formato fijo + plantilla siempre igual</a:t>
             </a:r>
           </a:p>
           <a:p>
@@ -10057,7 +10057,7 @@
                 </a:solidFill>
                 <a:latin typeface="Arial"/>
               </a:rPr>
-              <a:t>trazabilidad de prompts, criterios y scores</a:t>
+              <a:t>trazabilidad de las instrucciones a la IA, criterios y puntajes</a:t>
             </a:r>
           </a:p>
         </p:txBody>
@@ -10201,7 +10201,7 @@
                 </a:solidFill>
                 <a:latin typeface="Arial"/>
               </a:rPr>
-              <a:t>concordancia IA-vs-ojo clínico ≥ umbral en búsquedas reales; sin sesgo relevante; mejora medible de time-to-terna.</a:t>
+              <a:t>concordancia IA-vs-ojo clínico ≥ umbral en búsquedas reales; sin sesgo relevante; mejora medible del tiempo hasta la terna.</a:t>
             </a:r>
           </a:p>
         </p:txBody>
@@ -10577,7 +10577,7 @@
                 </a:solidFill>
                 <a:latin typeface="Arial"/>
               </a:rPr>
-              <a:t>horizonte · land-and-expand · desde US$15.000 o retainer US$3.500/mes</a:t>
+              <a:t>horizonte · entrar y crecer · desde US$15.000 o cuota fija US$3.500/mes</a:t>
             </a:r>
           </a:p>
         </p:txBody>
@@ -10716,7 +10716,7 @@
                 </a:solidFill>
                 <a:latin typeface="Arial"/>
               </a:rPr>
-              <a:t>parsing, golden record, score de vigencia → búsqueda por skill e internal-fill</a:t>
+              <a:t>lectura automática, ficha maestra única, puntaje de vigencia → búsqueda por competencia y cobertura con la base interna</a:t>
             </a:r>
           </a:p>
           <a:p>
@@ -10787,7 +10787,7 @@
                 </a:solidFill>
                 <a:latin typeface="Arial"/>
               </a:rPr>
-              <a:t>Decisión augmentar-vs-migrar Team Tailor: </a:t>
+              <a:t>Decisión de ampliar o migrar Team Tailor: </a:t>
             </a:r>
             <a:r>
               <a:rPr sz="1250" b="0">
@@ -10827,7 +10827,7 @@
                 </a:solidFill>
                 <a:latin typeface="Arial"/>
               </a:rPr>
-              <a:t>Benchmark de compensaciones: </a:t>
+              <a:t>Comparativo salarial de mercado: </a:t>
             </a:r>
             <a:r>
               <a:rPr sz="1250" b="0">
@@ -10836,7 +10836,7 @@
                 </a:solidFill>
                 <a:latin typeface="Arial"/>
               </a:rPr>
-              <a:t>solo con validación legal, k-anonimato y consentimiento — o alianza con proveedor licenciado</a:t>
+              <a:t>solo con validación legal, anonimización irreversible y consentimiento — o alianza con proveedor licenciado</a:t>
             </a:r>
           </a:p>
         </p:txBody>
@@ -11321,7 +11321,7 @@
                 </a:solidFill>
                 <a:latin typeface="Arial"/>
               </a:rPr>
-              <a:t>Un CV real anonimizado (por correo) — para el teaser del viernes.</a:t>
+              <a:t>Un CV real anonimizado (por correo) — para el adelanto del viernes.</a:t>
             </a:r>
           </a:p>
           <a:p>
@@ -11352,7 +11352,7 @@
                 </a:solidFill>
                 <a:latin typeface="Arial"/>
               </a:rPr>
-              <a:t>Acceso de lectura a Team Tailor — el lunes (lead time).</a:t>
+              <a:t>Acceso de lectura a Team Tailor — el lunes (toma unos días gestionarlo).</a:t>
             </a:r>
           </a:p>
           <a:p>
@@ -11758,7 +11758,7 @@
                 </a:solidFill>
                 <a:latin typeface="Arial"/>
               </a:rPr>
-              <a:t>Esta semana: CV anonimizado (o sintético) → teaser branded + registro anti-duplicado en vivo, con DPA.</a:t>
+              <a:t>Esta semana: CV anonimizado (o de prueba) → adelanto con tu marca + registro anti-duplicado en vivo, con acuerdo de protección de datos.</a:t>
             </a:r>
           </a:p>
         </p:txBody>
@@ -13518,7 +13518,7 @@
                 </a:solidFill>
                 <a:latin typeface="Arial"/>
               </a:rPr>
-              <a:t>. Tiene activos poco comunes: el ojo clínico de Virginia, un ATS y ~4.000 candidatos. Lo que falta no son herramientas: es la </a:t>
+              <a:t>. Tiene activos poco comunes: el ojo clínico de Virginia, su sistema de candidatos (Team Tailor) y ~4.000 perfiles. Lo que falta no son herramientas: es la </a:t>
             </a:r>
             <a:r>
               <a:rPr sz="1500" b="1">
@@ -16038,7 +16038,7 @@
                 </a:solidFill>
                 <a:latin typeface="Arial"/>
               </a:rPr>
-              <a:t>“Vendamos el benchmark salarial”   </a:t>
+              <a:t>“Vendamos el comparativo salarial de mercado”   </a:t>
             </a:r>
             <a:r>
               <a:rPr sz="1300" b="1">
@@ -16145,7 +16145,7 @@
                 </a:solidFill>
                 <a:latin typeface="Arial"/>
               </a:rPr>
-              <a:t>“Salir del ATS / mismo día”   </a:t>
+              <a:t>“Salir del sistema de candidatos (Team Tailor) / mismo día”   </a:t>
             </a:r>
             <a:r>
               <a:rPr sz="1300" b="1">
@@ -16812,7 +16812,7 @@
                 </a:solidFill>
                 <a:latin typeface="Arial"/>
               </a:rPr>
-              <a:t>Quick wins + prueba de valor con tus datos</a:t>
+              <a:t>Victorias rápidas + prueba de valor con tus datos</a:t>
             </a:r>
           </a:p>
           <a:p>
@@ -17716,7 +17716,7 @@
                 </a:solidFill>
                 <a:latin typeface="Arial"/>
               </a:rPr>
-              <a:t>20–30 CVs reales ordenados con tu criterio replicado — en un entorno con DPA, cumpliendo desde el día 1.</a:t>
+              <a:t>20–30 CVs reales ordenados con tu criterio replicado — en un entorno con acuerdo de protección de datos, cumpliendo desde el día 1.</a:t>
             </a:r>
           </a:p>
         </p:txBody>
@@ -18429,7 +18429,7 @@
                           </a:solidFill>
                           <a:latin typeface="Arial"/>
                         </a:rPr>
-                        <a:t>KPI</a:t>
+                        <a:t>Indicador</a:t>
                       </a:r>
                     </a:p>
                   </a:txBody>
@@ -18519,7 +18519,7 @@
                           </a:solidFill>
                           <a:latin typeface="Arial"/>
                         </a:rPr>
-                        <a:t>Time-to-terna</a:t>
+                        <a:t>Tiempo hasta la terna</a:t>
                       </a:r>
                     </a:p>
                   </a:txBody>
@@ -18811,7 +18811,7 @@
                           </a:solidFill>
                           <a:latin typeface="Arial"/>
                         </a:rPr>
-                        <a:t>% de mandatos cubiertos sin sourcing externo</a:t>
+                        <a:t>% de mandatos cubiertos sin búsqueda externa</a:t>
                       </a:r>
                     </a:p>
                   </a:txBody>
@@ -18969,7 +18969,7 @@
                           </a:solidFill>
                           <a:latin typeface="Arial"/>
                         </a:rPr>
-                        <a:t>Experiencia (CSAT)</a:t>
+                        <a:t>Experiencia (satisfacción)</a:t>
                       </a:r>
                     </a:p>
                   </a:txBody>
@@ -18991,7 +18991,7 @@
                           </a:solidFill>
                           <a:latin typeface="Arial"/>
                         </a:rPr>
-                        <a:t>% de candidatos satisfechos (con n)</a:t>
+                        <a:t>% de candidatos satisfechos (con muestra)</a:t>
                       </a:r>
                     </a:p>
                   </a:txBody>

</xml_diff>

<commit_message>
Consejo LLM #10: corregir el bug aritmético del crédito 100% — CIERRE (10/10)
- (alta) Tabla 'El horizonte completo' neteaba mal: mostraba la suma bruta ($12k/$24k/$39k)
  borrando el crédito del 100% prometido 4 veces. Neteada a ~$9.5k/~$21.5k/~$36.5k + nota.
  (cliente §5 + deck + nota interna ligada a la decisión de precio abierta).
- (media) Nombrar la palanca de F0 que da el 'mitad de tiempo' (activos de F0, no rúbrica de F1);
  acotar honestamente el n=1 (señal direccional, no prueba estadística).
- Descartada la mejora que re-inflaba F0; protocolo mantenido tight.
- 10 rondas completas. Las 6-10 (umbral alto) cazaron garantía amañada + bug aritmético.

Co-Authored-By: Claude Opus 4.8 <noreply@anthropic.com>
</commit_message>
<xml_diff>
--- a/04-propuesta/Presentacion-Conexion-Talento.pptx
+++ b/04-propuesta/Presentacion-Conexion-Talento.pptx
@@ -4994,7 +4994,7 @@
                 </a:solidFill>
                 <a:latin typeface="Arial"/>
               </a:rPr>
-              <a:t>~US$12.000</a:t>
+              <a:t>~US$9.500</a:t>
             </a:r>
           </a:p>
         </p:txBody>
@@ -5173,7 +5173,7 @@
                 </a:solidFill>
                 <a:latin typeface="Arial"/>
               </a:rPr>
-              <a:t>~US$24.000</a:t>
+              <a:t>~US$21.500</a:t>
             </a:r>
           </a:p>
         </p:txBody>
@@ -5352,7 +5352,7 @@
                 </a:solidFill>
                 <a:latin typeface="Arial"/>
               </a:rPr>
-              <a:t>desde ~US$39.000</a:t>
+              <a:t>desde ~US$36.500</a:t>
             </a:r>
           </a:p>
         </p:txBody>

</xml_diff>

<commit_message>
Finalización: marca Vértice + crédito parcial 50% + loop cerrado
- Firma = Vértice · Data, IA & Transformación Digital (portada, pie, cierre, orden de servicio,
  FIRM de render_pdf.py y build_pptx.py). Cero placeholders.
- Decisión de precio: crédito parcial 50% (F1 se queda en 9.500). Menciones '100% acreditable'
  → '50%'; netos del horizonte recalculados (Sistema ~10.750, +IA ~22.750, completo desde ~37.750).
- Loop de consejos cerrado (10/10) por decisión del usuario.

Co-Authored-By: Claude Opus 4.8 <noreply@anthropic.com>
</commit_message>
<xml_diff>
--- a/04-propuesta/Presentacion-Conexion-Talento.pptx
+++ b/04-propuesta/Presentacion-Conexion-Talento.pptx
@@ -3524,7 +3524,7 @@
                 </a:solidFill>
                 <a:latin typeface="Arial"/>
               </a:rPr>
-              <a:t>‹TU CONSULTORA› · Data, IA &amp; Transf. Digital</a:t>
+              <a:t>Vértice · Data, IA &amp; Transf. Digital</a:t>
             </a:r>
           </a:p>
         </p:txBody>
@@ -3833,7 +3833,7 @@
                 </a:solidFill>
                 <a:latin typeface="Arial"/>
               </a:rPr>
-              <a:t>‹TU CONSULTORA›   ·   10</a:t>
+              <a:t>Vértice   ·   10</a:t>
             </a:r>
           </a:p>
         </p:txBody>
@@ -4492,7 +4492,7 @@
                 </a:solidFill>
                 <a:latin typeface="Arial"/>
               </a:rPr>
-              <a:t>‹TU CONSULTORA›   ·   11</a:t>
+              <a:t>Vértice   ·   11</a:t>
             </a:r>
           </a:p>
         </p:txBody>
@@ -4649,7 +4649,7 @@
                 </a:solidFill>
                 <a:latin typeface="Arial"/>
               </a:rPr>
-              <a:t>Victorias rápidas + prueba de valor con tus datos · 2–3 semanas · 100% acreditable a la Fase 1</a:t>
+              <a:t>Victorias rápidas + prueba de valor con tus datos · 2–3 semanas · 50% acreditable a la Fase 1</a:t>
             </a:r>
           </a:p>
           <a:p>
@@ -4994,7 +4994,7 @@
                 </a:solidFill>
                 <a:latin typeface="Arial"/>
               </a:rPr>
-              <a:t>~US$9.500</a:t>
+              <a:t>~US$10.750</a:t>
             </a:r>
           </a:p>
         </p:txBody>
@@ -5173,7 +5173,7 @@
                 </a:solidFill>
                 <a:latin typeface="Arial"/>
               </a:rPr>
-              <a:t>~US$21.500</a:t>
+              <a:t>~US$22.750</a:t>
             </a:r>
           </a:p>
         </p:txBody>
@@ -5352,7 +5352,7 @@
                 </a:solidFill>
                 <a:latin typeface="Arial"/>
               </a:rPr>
-              <a:t>desde ~US$36.500</a:t>
+              <a:t>desde ~US$37.750</a:t>
             </a:r>
           </a:p>
         </p:txBody>
@@ -5692,7 +5692,7 @@
                 </a:solidFill>
                 <a:latin typeface="Arial"/>
               </a:rPr>
-              <a:t>‹TU CONSULTORA›   ·   12</a:t>
+              <a:t>Vértice   ·   12</a:t>
             </a:r>
           </a:p>
         </p:txBody>
@@ -6282,7 +6282,7 @@
                 </a:solidFill>
                 <a:latin typeface="Arial"/>
               </a:rPr>
-              <a:t>‹TU CONSULTORA›   ·   13</a:t>
+              <a:t>Vértice   ·   13</a:t>
             </a:r>
           </a:p>
         </p:txBody>
@@ -7128,7 +7128,7 @@
                 </a:solidFill>
                 <a:latin typeface="Arial"/>
               </a:rPr>
-              <a:t>* La Fase 0 acredita el 100% a la Fase 1. Cifras indicativas en USD, a calibrar con tu tarifa local y tu fee por colocación.</a:t>
+              <a:t>* La Fase 0 acredita el 50% (US$1.250) a la Fase 1. Cifras indicativas en USD, a calibrar con tu tarifa local y tu honorario por colocación.</a:t>
             </a:r>
           </a:p>
         </p:txBody>
@@ -7370,7 +7370,7 @@
                 </a:solidFill>
                 <a:latin typeface="Arial"/>
               </a:rPr>
-              <a:t>‹TU CONSULTORA›   ·   14</a:t>
+              <a:t>Vértice   ·   14</a:t>
             </a:r>
           </a:p>
         </p:txBody>
@@ -8885,7 +8885,7 @@
                 </a:solidFill>
                 <a:latin typeface="Arial"/>
               </a:rPr>
-              <a:t>‹TU CONSULTORA›   ·   15</a:t>
+              <a:t>Vértice   ·   15</a:t>
             </a:r>
           </a:p>
         </p:txBody>
@@ -9704,7 +9704,7 @@
                 </a:solidFill>
                 <a:latin typeface="Arial"/>
               </a:rPr>
-              <a:t>‹TU CONSULTORA›   ·   16</a:t>
+              <a:t>Vértice   ·   16</a:t>
             </a:r>
           </a:p>
         </p:txBody>
@@ -10443,7 +10443,7 @@
                 </a:solidFill>
                 <a:latin typeface="Arial"/>
               </a:rPr>
-              <a:t>‹TU CONSULTORA›   ·   17</a:t>
+              <a:t>Vértice   ·   17</a:t>
             </a:r>
           </a:p>
         </p:txBody>
@@ -11222,7 +11222,7 @@
                 </a:solidFill>
                 <a:latin typeface="Arial"/>
               </a:rPr>
-              <a:t>‹TU CONSULTORA›   ·   18</a:t>
+              <a:t>Vértice   ·   18</a:t>
             </a:r>
           </a:p>
         </p:txBody>
@@ -12155,7 +12155,7 @@
                 </a:solidFill>
                 <a:latin typeface="Arial"/>
               </a:rPr>
-              <a:t>Gracias, Virginia. — ‹TU CONSULTORA› · Data, IA &amp; Transformación Digital</a:t>
+              <a:t>Gracias, Virginia. — Vértice · Data, IA &amp; Transformación Digital</a:t>
             </a:r>
           </a:p>
         </p:txBody>
@@ -12397,7 +12397,7 @@
                 </a:solidFill>
                 <a:latin typeface="Arial"/>
               </a:rPr>
-              <a:t>‹TU CONSULTORA›   ·   2</a:t>
+              <a:t>Vértice   ·   2</a:t>
             </a:r>
           </a:p>
         </p:txBody>
@@ -13455,7 +13455,7 @@
                 </a:solidFill>
                 <a:latin typeface="Arial"/>
               </a:rPr>
-              <a:t>‹TU CONSULTORA›   ·   3</a:t>
+              <a:t>Vértice   ·   3</a:t>
             </a:r>
           </a:p>
         </p:txBody>
@@ -14036,7 +14036,7 @@
                 </a:solidFill>
                 <a:latin typeface="Arial"/>
               </a:rPr>
-              <a:t>‹TU CONSULTORA›   ·   4</a:t>
+              <a:t>Vértice   ·   4</a:t>
             </a:r>
           </a:p>
         </p:txBody>
@@ -14623,7 +14623,7 @@
                 </a:solidFill>
                 <a:latin typeface="Arial"/>
               </a:rPr>
-              <a:t>‹TU CONSULTORA›   ·   5</a:t>
+              <a:t>Vértice   ·   5</a:t>
             </a:r>
           </a:p>
         </p:txBody>
@@ -15583,7 +15583,7 @@
                 </a:solidFill>
                 <a:latin typeface="Arial"/>
               </a:rPr>
-              <a:t>‹TU CONSULTORA›   ·   6</a:t>
+              <a:t>Vértice   ·   6</a:t>
             </a:r>
           </a:p>
         </p:txBody>
@@ -16549,7 +16549,7 @@
                 </a:solidFill>
                 <a:latin typeface="Arial"/>
               </a:rPr>
-              <a:t>‹TU CONSULTORA›   ·   7</a:t>
+              <a:t>Vértice   ·   7</a:t>
             </a:r>
           </a:p>
         </p:txBody>
@@ -16843,7 +16843,7 @@
                 </a:solidFill>
                 <a:latin typeface="Arial"/>
               </a:rPr>
-              <a:t>100% acreditable a la siguiente fase</a:t>
+              <a:t>50% acreditable a la siguiente fase</a:t>
             </a:r>
           </a:p>
           <a:p>
@@ -17385,7 +17385,7 @@
                 </a:solidFill>
                 <a:latin typeface="Arial"/>
               </a:rPr>
-              <a:t>‹TU CONSULTORA›   ·   8</a:t>
+              <a:t>Vértice   ·   8</a:t>
             </a:r>
           </a:p>
         </p:txBody>
@@ -18387,7 +18387,7 @@
                 </a:solidFill>
                 <a:latin typeface="Arial"/>
               </a:rPr>
-              <a:t>‹TU CONSULTORA›   ·   9</a:t>
+              <a:t>Vértice   ·   9</a:t>
             </a:r>
           </a:p>
         </p:txBody>

</xml_diff>

<commit_message>
Consejo LLM #12 (QA): cerrar el hueco de $1.000 en la Fase 2
- (alta) Fase 2 se vendía a $12k bajo 'pagas solo los módulos que apruebas' pero los módulos con
  precio sumaban $11k (Screener $7k + Generador $4k); el 3er entregable (medición/auditoría) no
  llevaba precio → etiquetado ~$1.000. Ahora $7k+$4k+$1k=$12k, en PDF y deck (verificado).
- (media) Subido el 'por qué AHORA' al resumen ejecutivo: brecha de privacidad activa vs Decreto
  144/2024 = pasivo legal diario, para desarmar la muerte por no-decisión.
- QA (rondas 11-12) cazó 2 bugs de honestidad que 10 rondas no vieron.

Co-Authored-By: Claude Opus 4.8 <noreply@anthropic.com>
</commit_message>
<xml_diff>
--- a/04-propuesta/Presentacion-Conexion-Talento.pptx
+++ b/04-propuesta/Presentacion-Conexion-Talento.pptx
@@ -10048,7 +10048,7 @@
                 </a:solidFill>
                 <a:latin typeface="Arial"/>
               </a:rPr>
-              <a:t>Medición vs línea base + auditoría de sesgo: </a:t>
+              <a:t>Medición vs línea base + auditoría de sesgo (~US$1.000): </a:t>
             </a:r>
             <a:r>
               <a:rPr sz="1250" b="0">
@@ -10057,7 +10057,7 @@
                 </a:solidFill>
                 <a:latin typeface="Arial"/>
               </a:rPr>
-              <a:t>trazabilidad de las instrucciones a la IA, criterios y puntajes</a:t>
+              <a:t>$7k + $4k + $1k = los US$12.000 de la fase; trazabilidad de instrucciones, criterios y puntajes</a:t>
             </a:r>
           </a:p>
         </p:txBody>

</xml_diff>

<commit_message>
Pase de claridad ejecutiva final: doc cliente + deck más claros y sin sobre-defensa
- Loop cerrado, sin más consejo (decisión del usuario).
- Doc cliente y deck simplificados a lenguaje ejecutivo y des-inflados: se quitó la sobre-defensa
  acumulada en 14 rondas ('seguro de cartón', 'sin amaños', 'sin letra chica', caveats apilados,
  redundancia de 'solo decides la Fase 0'), des-jergonizado el deck ('Caveat'→'La condición').
- Verificado contra git HEAD cifra por cifra: cero números/secciones/compromisos perdidos; §8
  completa, orden de servicio íntegra con firmas. KPI '5 d' marcado 'a medir' (honestidad).
- Aplicados de paso los 2 últimos fixes de honestidad: KPI baseline + escape hatch de la auditoría.
- Entregables finales: PDF 21pp + deck 19 slides, marca Vértice, crédito 50%.

Co-Authored-By: Claude Opus 4.8 <noreply@anthropic.com>
</commit_message>
<xml_diff>
--- a/04-propuesta/Presentacion-Conexion-Talento.pptx
+++ b/04-propuesta/Presentacion-Conexion-Talento.pptx
@@ -4147,7 +4147,7 @@
                 </a:solidFill>
                 <a:latin typeface="Arial"/>
               </a:rPr>
-              <a:t>(Números de marcador, no promesa.)</a:t>
+              <a:t>(Cifras de ejemplo.)</a:t>
             </a:r>
           </a:p>
         </p:txBody>
@@ -4201,7 +4201,7 @@
                 </a:solidFill>
                 <a:latin typeface="Arial"/>
               </a:rPr>
-              <a:t>Lo honesto: </a:t>
+              <a:t>Con tu fee real: </a:t>
             </a:r>
             <a:r>
               <a:rPr sz="1350" b="0">
@@ -4210,7 +4210,7 @@
                 </a:solidFill>
                 <a:latin typeface="Arial"/>
               </a:rPr>
-              <a:t>el ejemplo usa un fee conservador supuesto —prudente, no inflado—. El caso ya se sostiene; si me pasas tu fee real cuando puedas, lo afino. No es tarea para hoy.</a:t>
+              <a:t>el ejemplo usa un fee conservador. Pásame el tuyo cuando puedas y lo afino — no es tarea para hoy.</a:t>
             </a:r>
           </a:p>
           <a:p>
@@ -4241,7 +4241,7 @@
                 </a:solidFill>
                 <a:latin typeface="Arial"/>
               </a:rPr>
-              <a:t>Caveat: </a:t>
+              <a:t>La condición: </a:t>
             </a:r>
             <a:r>
               <a:rPr sz="1350" b="0">
@@ -4250,7 +4250,7 @@
                 </a:solidFill>
                 <a:latin typeface="Arial"/>
               </a:rPr>
-              <a:t>aplica solo si hoy pierdes mandatos por velocidad —no si tienes capacidad ociosa—; esa es la primera pregunta de nuestra primera sesión. La velocidad te pone primera en la fila; no prometemos colocaciones.</a:t>
+              <a:t>la velocidad te pone primera en la fila, no garantiza la colocación. Esto rinde si hoy pierdes mandatos por lentitud, no si tienes gente ociosa — es la primera pregunta de nuestra sesión inicial.</a:t>
             </a:r>
           </a:p>
         </p:txBody>
@@ -4671,7 +4671,7 @@
                 </a:solidFill>
                 <a:latin typeface="Arial"/>
               </a:rPr>
-              <a:t>Tu seguro: te quedas los activos; avanzas a la Fase 1 solo si la Puerta 0 pasa su vara objetiva. Sin letra chica.</a:t>
+              <a:t>Tu seguro: te quedas los activos y avanzas a la Fase 1 solo si la Puerta 0 pasa su vara objetiva.</a:t>
             </a:r>
           </a:p>
         </p:txBody>
@@ -4815,7 +4815,7 @@
                 </a:solidFill>
                 <a:latin typeface="Arial"/>
               </a:rPr>
-              <a:t>El horizonte completo (referencia — no es lo que decides hoy; cada fase se cotiza y firma por separado):</a:t>
+              <a:t>El horizonte completo (solo de referencia):</a:t>
             </a:r>
           </a:p>
         </p:txBody>
@@ -6148,7 +6148,7 @@
                 </a:solidFill>
                 <a:latin typeface="Arial"/>
               </a:rPr>
-              <a:t>Las cuatro fases — el mapa, no el pedido de hoy</a:t>
+              <a:t>Las cuatro fases — el mapa completo</a:t>
             </a:r>
           </a:p>
         </p:txBody>
@@ -8581,7 +8581,7 @@
                 </a:solidFill>
                 <a:latin typeface="Arial"/>
               </a:rPr>
-              <a:t>Hoy decides la Fase 0 (semanas 1–3). Lo demás se cotiza al pasar cada puerta.</a:t>
+              <a:t>La Fase 0 corre en las semanas 1–3; cada fase siguiente se cotiza al pasar su puerta.</a:t>
             </a:r>
           </a:p>
           <a:p>
@@ -18563,7 +18563,7 @@
                           </a:solidFill>
                           <a:latin typeface="Arial"/>
                         </a:rPr>
-                        <a:t>~5 días</a:t>
+                        <a:t>~5 días (a medir)</a:t>
                       </a:r>
                     </a:p>
                   </a:txBody>

</xml_diff>